<commit_message>
feat(parte-13): profundizar auditoria de hardware y radio
</commit_message>
<xml_diff>
--- a/classes/parte-13-seguridad-movil-iot-e-inalambrica/268-analisis-de-hardware-uart-jtag-y-spi/clase-268-presentacion.pptx
+++ b/classes/parte-13-seguridad-movil-iot-e-inalambrica/268-analisis-de-hardware-uart-jtag-y-spi/clase-268-presentacion.pptx
@@ -3131,7 +3131,7 @@
                   <a:srgbClr val="0B3D2E"/>
                 </a:solidFill>
               </a:rPr>
-              <a:t>Clase 268 — Análisis de hardware: UART, JTAG y SPI</a:t>
+              <a:t>Clase 268 — Análisis de hardware: UART, JTAG/SWD y SPI</a:t>
             </a:r>
           </a:p>
           <a:p>
@@ -3202,7 +3202,7 @@
                   <a:srgbClr val="0B3D2E"/>
                 </a:solidFill>
               </a:rPr>
-              <a:t>🧪 Laboratorio guiado</a:t>
+              <a:t>🧪 Laboratorio guiado — Del pin desconocido a una captura defendible</a:t>
             </a:r>
           </a:p>
         </p:txBody>
@@ -3240,97 +3240,97 @@
                   <a:srgbClr val="22282E"/>
                 </a:solidFill>
               </a:rPr>
-              <a:t>•  Inspecciona la PCB de un dispositivo propio: busca cabeceras de 4 pines (UART) y de 2x5/10 pines (JTAG), y el chip de flash (SOIC-8).</a:t>
-            </a:r>
-          </a:p>
-          <a:p>
-            <a:pPr>
-              <a:spcAft>
-                <a:spcPts val="600"/>
-              </a:spcAft>
-            </a:pPr>
-            <a:r>
-              <a:rPr sz="1500">
-                <a:solidFill>
-                  <a:srgbClr val="22282E"/>
-                </a:solidFill>
-              </a:rPr>
-              <a:t>•  Identifica el pinout UART: con el multímetro localiza GND (continuidad al plano de tierra), VCC (~3.3 V), y usa el analizador lógico para hallar TX (actividad al arrancar) y el baud rate.</a:t>
-            </a:r>
-          </a:p>
-          <a:p>
-            <a:pPr>
-              <a:spcAft>
-                <a:spcPts val="600"/>
-              </a:spcAft>
-            </a:pPr>
-            <a:r>
-              <a:rPr sz="1500">
-                <a:solidFill>
-                  <a:srgbClr val="22282E"/>
-                </a:solidFill>
-              </a:rPr>
-              <a:t>•  Conecta el adaptador UART (TX↔RX cruzados, GND común, sin conectar VCC si el equipo se auto-alimenta) y abre la consola con screen.</a:t>
-            </a:r>
-          </a:p>
-          <a:p>
-            <a:pPr>
-              <a:spcAft>
-                <a:spcPts val="600"/>
-              </a:spcAft>
-            </a:pPr>
-            <a:r>
-              <a:rPr sz="1500">
-                <a:solidFill>
-                  <a:srgbClr val="22282E"/>
-                </a:solidFill>
-              </a:rPr>
-              <a:t>•  Captura el arranque: observa los logs de U-Boot; intenta interrumpirlo para entrar a su consola.</a:t>
-            </a:r>
-          </a:p>
-          <a:p>
-            <a:pPr>
-              <a:spcAft>
-                <a:spcPts val="600"/>
-              </a:spcAft>
-            </a:pPr>
-            <a:r>
-              <a:rPr sz="1500">
-                <a:solidFill>
-                  <a:srgbClr val="22282E"/>
-                </a:solidFill>
-              </a:rPr>
-              <a:t>•  Busca shell: al terminar el arranque, comprueba si hay una consola root sin contraseña.</a:t>
-            </a:r>
-          </a:p>
-          <a:p>
-            <a:pPr>
-              <a:spcAft>
-                <a:spcPts val="600"/>
-              </a:spcAft>
-            </a:pPr>
-            <a:r>
-              <a:rPr sz="1500">
-                <a:solidFill>
-                  <a:srgbClr val="22282E"/>
-                </a:solidFill>
-              </a:rPr>
-              <a:t>•  JTAG/SWD: conecta el adaptador, lanza OpenOCD, halt el CPU y dumpimage de la flash/RAM.</a:t>
-            </a:r>
-          </a:p>
-          <a:p>
-            <a:pPr>
-              <a:spcAft>
-                <a:spcPts val="600"/>
-              </a:spcAft>
-            </a:pPr>
-            <a:r>
-              <a:rPr sz="1500">
-                <a:solidFill>
-                  <a:srgbClr val="22282E"/>
-                </a:solidFill>
-              </a:rPr>
-              <a:t>•  SPI directo: con la pinza SOIC sobre el chip de flash, vuelca su contenido con flashrom y analízalo con binwalk (clase 267).</a:t>
+              <a:t>•  Objetivo. Identificar UART y una segunda evidencia pasiva —captura SPI o segundo log— en una placa educativa, sin modificarla.</a:t>
+            </a:r>
+          </a:p>
+          <a:p>
+            <a:pPr>
+              <a:spcAft>
+                <a:spcPts val="600"/>
+              </a:spcAft>
+            </a:pPr>
+            <a:r>
+              <a:rPr sz="1500">
+                <a:solidFill>
+                  <a:srgbClr val="22282E"/>
+                </a:solidFill>
+              </a:rPr>
+              <a:t>•  Prerrequisitos. Clases 004, 026, 267 y 025; habilidades básicas de multímetro; autorización del propietario; placa sin conexión a producción.</a:t>
+            </a:r>
+          </a:p>
+          <a:p>
+            <a:pPr>
+              <a:spcAft>
+                <a:spcPts val="600"/>
+              </a:spcAft>
+            </a:pPr>
+            <a:r>
+              <a:rPr sz="1500">
+                <a:solidFill>
+                  <a:srgbClr val="22282E"/>
+                </a:solidFill>
+              </a:rPr>
+              <a:t>•  Topología. Placa objetivo alimentada por su fuente → GND común → analizador lógico. El adaptador UART se conecta solo después de confirmar nivel. El portátil de análisis permanece sin conexión a…</a:t>
+            </a:r>
+          </a:p>
+          <a:p>
+            <a:pPr>
+              <a:spcAft>
+                <a:spcPts val="600"/>
+              </a:spcAft>
+            </a:pPr>
+            <a:r>
+              <a:rPr sz="1500">
+                <a:solidFill>
+                  <a:srgbClr val="22282E"/>
+                </a:solidFill>
+              </a:rPr>
+              <a:t>•  Procedimiento.</a:t>
+            </a:r>
+          </a:p>
+          <a:p>
+            <a:pPr>
+              <a:spcAft>
+                <a:spcPts val="600"/>
+              </a:spcAft>
+            </a:pPr>
+            <a:r>
+              <a:rPr sz="1500">
+                <a:solidFill>
+                  <a:srgbClr val="22282E"/>
+                </a:solidFill>
+              </a:rPr>
+              <a:t>•  Asigna un ID al DUT y registra modelo, revisión, estado, firmware visible y fotos. Descarga datasheets desde fuentes primarias.</a:t>
+            </a:r>
+          </a:p>
+          <a:p>
+            <a:pPr>
+              <a:spcAft>
+                <a:spcPts val="600"/>
+              </a:spcAft>
+            </a:pPr>
+            <a:r>
+              <a:rPr sz="1500">
+                <a:solidFill>
+                  <a:srgbClr val="22282E"/>
+                </a:solidFill>
+              </a:rPr>
+              <a:t>•  Con el DUT apagado, localiza GND por continuidad. Marca pines candidatos sin soldar ni raspar pistas.</a:t>
+            </a:r>
+          </a:p>
+          <a:p>
+            <a:pPr>
+              <a:spcAft>
+                <a:spcPts val="600"/>
+              </a:spcAft>
+            </a:pPr>
+            <a:r>
+              <a:rPr sz="1500">
+                <a:solidFill>
+                  <a:srgbClr val="22282E"/>
+                </a:solidFill>
+              </a:rPr>
+              <a:t>•  Alimenta con su fuente y mide cada candidato respecto de GND. Detén la práctica ante tensión inesperada, calentamiento u olor.</a:t>
             </a:r>
           </a:p>
         </p:txBody>
@@ -3419,82 +3419,82 @@
                   <a:srgbClr val="22282E"/>
                 </a:solidFill>
               </a:rPr>
-              <a:t>•  Identifica y etiqueta el pinout UART de una placa propia usando multímetro y analizador lógico.</a:t>
-            </a:r>
-          </a:p>
-          <a:p>
-            <a:pPr>
-              <a:spcAft>
-                <a:spcPts val="600"/>
-              </a:spcAft>
-            </a:pPr>
-            <a:r>
-              <a:rPr sz="1500">
-                <a:solidFill>
-                  <a:srgbClr val="22282E"/>
-                </a:solidFill>
-              </a:rPr>
-              <a:t>•  Captura y guarda el log de arranque completo por UART.</a:t>
-            </a:r>
-          </a:p>
-          <a:p>
-            <a:pPr>
-              <a:spcAft>
-                <a:spcPts val="600"/>
-              </a:spcAft>
-            </a:pPr>
-            <a:r>
-              <a:rPr sz="1500">
-                <a:solidFill>
-                  <a:srgbClr val="22282E"/>
-                </a:solidFill>
-              </a:rPr>
-              <a:t>•  Interrumpe U-Boot y lista sus variables de entorno.</a:t>
-            </a:r>
-          </a:p>
-          <a:p>
-            <a:pPr>
-              <a:spcAft>
-                <a:spcPts val="600"/>
-              </a:spcAft>
-            </a:pPr>
-            <a:r>
-              <a:rPr sz="1500">
-                <a:solidFill>
-                  <a:srgbClr val="22282E"/>
-                </a:solidFill>
-              </a:rPr>
-              <a:t>•  Vuelca el flash SPI con flashrom y verifica su tamaño esperado.</a:t>
-            </a:r>
-          </a:p>
-          <a:p>
-            <a:pPr>
-              <a:spcAft>
-                <a:spcPts val="600"/>
-              </a:spcAft>
-            </a:pPr>
-            <a:r>
-              <a:rPr sz="1500">
-                <a:solidFill>
-                  <a:srgbClr val="22282E"/>
-                </a:solidFill>
-              </a:rPr>
-              <a:t>•  Con OpenOCD, detén el CPU y lee una región de memoria.</a:t>
-            </a:r>
-          </a:p>
-          <a:p>
-            <a:pPr>
-              <a:spcAft>
-                <a:spcPts val="600"/>
-              </a:spcAft>
-            </a:pPr>
-            <a:r>
-              <a:rPr sz="1500">
-                <a:solidFill>
-                  <a:srgbClr val="22282E"/>
-                </a:solidFill>
-              </a:rPr>
-              <a:t>•  Compara el firmware obtenido por SPI con la descarga oficial (si existe).</a:t>
+              <a:t>•  Explica por qué RX/TX cruzados no justifican conectar VCC.</a:t>
+            </a:r>
+          </a:p>
+          <a:p>
+            <a:pPr>
+              <a:spcAft>
+                <a:spcPts val="600"/>
+              </a:spcAft>
+            </a:pPr>
+            <a:r>
+              <a:rPr sz="1500">
+                <a:solidFill>
+                  <a:srgbClr val="22282E"/>
+                </a:solidFill>
+              </a:rPr>
+              <a:t>•  Dado un log UART de solo salida, enumera qué evidencia falta para afirmar «shell root».</a:t>
+            </a:r>
+          </a:p>
+          <a:p>
+            <a:pPr>
+              <a:spcAft>
+                <a:spcPts val="600"/>
+              </a:spcAft>
+            </a:pPr>
+            <a:r>
+              <a:rPr sz="1500">
+                <a:solidFill>
+                  <a:srgbClr val="22282E"/>
+                </a:solidFill>
+              </a:rPr>
+              <a:t>•  Compara analizador lógico, Bus Pirate y sonda SWD para investigar una EEPROM SPI.</a:t>
+            </a:r>
+          </a:p>
+          <a:p>
+            <a:pPr>
+              <a:spcAft>
+                <a:spcPts val="600"/>
+              </a:spcAft>
+            </a:pPr>
+            <a:r>
+              <a:rPr sz="1500">
+                <a:solidFill>
+                  <a:srgbClr val="22282E"/>
+                </a:solidFill>
+              </a:rPr>
+              <a:t>•  Diseña un control de producción que deshabilite debug sin impedir recuperación autorizada.</a:t>
+            </a:r>
+          </a:p>
+          <a:p>
+            <a:pPr>
+              <a:spcAft>
+                <a:spcPts val="600"/>
+              </a:spcAft>
+            </a:pPr>
+            <a:r>
+              <a:rPr sz="1500">
+                <a:solidFill>
+                  <a:srgbClr val="22282E"/>
+                </a:solidFill>
+              </a:rPr>
+              <a:t>•  Ante dos volcados diferentes en 37 bytes, plantea un diagnóstico eléctrico antes de interpretar firmware.</a:t>
+            </a:r>
+          </a:p>
+          <a:p>
+            <a:pPr>
+              <a:spcAft>
+                <a:spcPts val="600"/>
+              </a:spcAft>
+            </a:pPr>
+            <a:r>
+              <a:rPr sz="1500">
+                <a:solidFill>
+                  <a:srgbClr val="22282E"/>
+                </a:solidFill>
+              </a:rPr>
+              <a:t>•  Define los prerrequisitos que faltan antes de iniciar un laboratorio ChipWhisperer.</a:t>
             </a:r>
           </a:p>
         </p:txBody>
@@ -3583,7 +3583,22 @@
                   <a:srgbClr val="22282E"/>
                 </a:solidFill>
               </a:rPr>
-              <a:t>•  Obtén evidencia de un dispositivo de laboratorio por dos observaciones no destructivas —por ejemplo, log UART y dos lecturas SPI coincidentes—. Criterio de aceptación: documentas pinout, niveles…</a:t>
+              <a:t>•  Entrega un cuaderno de banco con fotos, hipótesis, medidas, pinout, parámetros, captura anotada, comandos exactos, hashes, límites, controles y restauración.</a:t>
+            </a:r>
+          </a:p>
+          <a:p>
+            <a:pPr>
+              <a:spcAft>
+                <a:spcPts val="600"/>
+              </a:spcAft>
+            </a:pPr>
+            <a:r>
+              <a:rPr sz="1500">
+                <a:solidFill>
+                  <a:srgbClr val="22282E"/>
+                </a:solidFill>
+              </a:rPr>
+              <a:t>•  Criterio de aceptación: ninguna conexión se basó solo en apariencia; el alumno demuestra por qué la captura corresponde al protocolo; toda lectura activa es repetible; no se escribe flash ni se…</a:t>
             </a:r>
           </a:p>
         </p:txBody>
@@ -3672,67 +3687,82 @@
                   <a:srgbClr val="22282E"/>
                 </a:solidFill>
               </a:rPr>
-              <a:t>•  Consola serie muestra basura — Baud rate incorrecto; prueba 9600/57600/115200</a:t>
-            </a:r>
-          </a:p>
-          <a:p>
-            <a:pPr>
-              <a:spcAft>
-                <a:spcPts val="600"/>
-              </a:spcAft>
-            </a:pPr>
-            <a:r>
-              <a:rPr sz="1500">
-                <a:solidFill>
-                  <a:srgbClr val="22282E"/>
-                </a:solidFill>
-              </a:rPr>
-              <a:t>•  No hay salida por UART — TX/RX invertidos o pin equivocado; cruza TX↔RX y reidentifica</a:t>
-            </a:r>
-          </a:p>
-          <a:p>
-            <a:pPr>
-              <a:spcAft>
-                <a:spcPts val="600"/>
-              </a:spcAft>
-            </a:pPr>
-            <a:r>
-              <a:rPr sz="1500">
-                <a:solidFill>
-                  <a:srgbClr val="22282E"/>
-                </a:solidFill>
-              </a:rPr>
-              <a:t>•  Dispositivo se reinicia al conectar — Alimentaste VCC indebidamente; no conectes VCC si se auto-alimenta</a:t>
-            </a:r>
-          </a:p>
-          <a:p>
-            <a:pPr>
-              <a:spcAft>
-                <a:spcPts val="600"/>
-              </a:spcAft>
-            </a:pPr>
-            <a:r>
-              <a:rPr sz="1500">
-                <a:solidFill>
-                  <a:srgbClr val="22282E"/>
-                </a:solidFill>
-              </a:rPr>
-              <a:t>•  OpenOCD no detecta el target — Archivo de config equivocado o JTAG deshabilitado por fusible</a:t>
-            </a:r>
-          </a:p>
-          <a:p>
-            <a:pPr>
-              <a:spcAft>
-                <a:spcPts val="600"/>
-              </a:spcAft>
-            </a:pPr>
-            <a:r>
-              <a:rPr sz="1500">
-                <a:solidFill>
-                  <a:srgbClr val="22282E"/>
-                </a:solidFill>
-              </a:rPr>
-              <a:t>•  flashrom no reconoce el chip — Mal contacto de la pinza o chip no soportado; especifica -c manualmente</a:t>
+              <a:t>•  Texto ilegible en UART — baud/formato/nivel incorrecto o ruido</a:t>
+            </a:r>
+          </a:p>
+          <a:p>
+            <a:pPr>
+              <a:spcAft>
+                <a:spcPts val="600"/>
+              </a:spcAft>
+            </a:pPr>
+            <a:r>
+              <a:rPr sz="1500">
+                <a:solidFill>
+                  <a:srgbClr val="22282E"/>
+                </a:solidFill>
+              </a:rPr>
+              <a:t>•  No hay salida — pin equivocado, consola deshabilitada o ventana perdida</a:t>
+            </a:r>
+          </a:p>
+          <a:p>
+            <a:pPr>
+              <a:spcAft>
+                <a:spcPts val="600"/>
+              </a:spcAft>
+            </a:pPr>
+            <a:r>
+              <a:rPr sz="1500">
+                <a:solidFill>
+                  <a:srgbClr val="22282E"/>
+                </a:solidFill>
+              </a:rPr>
+              <a:t>•  OpenOCD no encuentra target — sonda, pinout, reset o archivo incorrectos; protección activa</a:t>
+            </a:r>
+          </a:p>
+          <a:p>
+            <a:pPr>
+              <a:spcAft>
+                <a:spcPts val="600"/>
+              </a:spcAft>
+            </a:pPr>
+            <a:r>
+              <a:rPr sz="1500">
+                <a:solidFill>
+                  <a:srgbClr val="22282E"/>
+                </a:solidFill>
+              </a:rPr>
+              <a:t>•  Hashes SPI difieren — contacto, alimentación o contención</a:t>
+            </a:r>
+          </a:p>
+          <a:p>
+            <a:pPr>
+              <a:spcAft>
+                <a:spcPts val="600"/>
+              </a:spcAft>
+            </a:pPr>
+            <a:r>
+              <a:rPr sz="1500">
+                <a:solidFill>
+                  <a:srgbClr val="22282E"/>
+                </a:solidFill>
+              </a:rPr>
+              <a:t>•  El DUT deja de arrancar — alimentación o escritura accidental</a:t>
+            </a:r>
+          </a:p>
+          <a:p>
+            <a:pPr>
+              <a:spcAft>
+                <a:spcPts val="600"/>
+              </a:spcAft>
+            </a:pPr>
+            <a:r>
+              <a:rPr sz="1500">
+                <a:solidFill>
+                  <a:srgbClr val="22282E"/>
+                </a:solidFill>
+              </a:rPr>
+              <a:t>•  «JTAG presente = memoria extraíble» — confunde interfaz con autorización/capacidad</a:t>
             </a:r>
           </a:p>
         </p:txBody>
@@ -3821,82 +3851,52 @@
                   <a:srgbClr val="22282E"/>
                 </a:solidFill>
               </a:rPr>
-              <a:t>•  ❓ ¿Cómo sé qué pin es UART sin documentación?</a:t>
-            </a:r>
-          </a:p>
-          <a:p>
-            <a:pPr>
-              <a:spcAft>
-                <a:spcPts val="600"/>
-              </a:spcAft>
-            </a:pPr>
-            <a:r>
-              <a:rPr sz="1500">
-                <a:solidFill>
-                  <a:srgbClr val="22282E"/>
-                </a:solidFill>
-              </a:rPr>
-              <a:t>•  Mide con multímetro (GND por continuidad, VCC ~3.3 V estable) y con el analizador lógico observa qué pin tiene ráfagas de datos al encender: ese es TX.</a:t>
-            </a:r>
-          </a:p>
-          <a:p>
-            <a:pPr>
-              <a:spcAft>
-                <a:spcPts val="600"/>
-              </a:spcAft>
-            </a:pPr>
-            <a:r>
-              <a:rPr sz="1500">
-                <a:solidFill>
-                  <a:srgbClr val="22282E"/>
-                </a:solidFill>
-              </a:rPr>
-              <a:t>•  ❓ ¿Puedo dañar el dispositivo?</a:t>
-            </a:r>
-          </a:p>
-          <a:p>
-            <a:pPr>
-              <a:spcAft>
-                <a:spcPts val="600"/>
-              </a:spcAft>
-            </a:pPr>
-            <a:r>
-              <a:rPr sz="1500">
-                <a:solidFill>
-                  <a:srgbClr val="22282E"/>
-                </a:solidFill>
-              </a:rPr>
-              <a:t>•  Sí, si aplicas voltaje incorrecto o cortocircuitas pines. Trabaja a 3.3 V, verifica antes de conectar VCC y usa un adaptador con el mismo nivel lógico.</a:t>
-            </a:r>
-          </a:p>
-          <a:p>
-            <a:pPr>
-              <a:spcAft>
-                <a:spcPts val="600"/>
-              </a:spcAft>
-            </a:pPr>
-            <a:r>
-              <a:rPr sz="1500">
-                <a:solidFill>
-                  <a:srgbClr val="22282E"/>
-                </a:solidFill>
-              </a:rPr>
-              <a:t>•  ❓ ¿Por qué usar SPI si ya tengo UART?</a:t>
-            </a:r>
-          </a:p>
-          <a:p>
-            <a:pPr>
-              <a:spcAft>
-                <a:spcPts val="600"/>
-              </a:spcAft>
-            </a:pPr>
-            <a:r>
-              <a:rPr sz="1500">
-                <a:solidFill>
-                  <a:srgbClr val="22282E"/>
-                </a:solidFill>
-              </a:rPr>
-              <a:t>•  UART puede no dar shell o exponer solo parte del sistema; leer el flash por SPI extrae la imagen completa aunque el software lo impida.</a:t>
+              <a:t>•  ¿Puedo usar un CH341A directamente? Solo si la revisión, tensión y chip son compatibles. El nombre del programador no garantiza nivel correcto ni seguridad in circuit.</a:t>
+            </a:r>
+          </a:p>
+          <a:p>
+            <a:pPr>
+              <a:spcAft>
+                <a:spcPts val="600"/>
+              </a:spcAft>
+            </a:pPr>
+            <a:r>
+              <a:rPr sz="1500">
+                <a:solidFill>
+                  <a:srgbClr val="22282E"/>
+                </a:solidFill>
+              </a:rPr>
+              <a:t>•  ¿Quitar el conector protege JTAG? Dificulta acceso, pero test points y pistas pueden seguir disponibles. Debe combinarse con protección del silicio y firmware firmado.</a:t>
+            </a:r>
+          </a:p>
+          <a:p>
+            <a:pPr>
+              <a:spcAft>
+                <a:spcPts val="600"/>
+              </a:spcAft>
+            </a:pPr>
+            <a:r>
+              <a:rPr sz="1500">
+                <a:solidFill>
+                  <a:srgbClr val="22282E"/>
+                </a:solidFill>
+              </a:rPr>
+              <a:t>•  ¿Bus Pirate reemplaza todo el banco? No. Integra muchas funciones de baja velocidad, pero multímetro, analizador dedicado y sonda de depuración responden preguntas distintas.</a:t>
+            </a:r>
+          </a:p>
+          <a:p>
+            <a:pPr>
+              <a:spcAft>
+                <a:spcPts val="600"/>
+              </a:spcAft>
+            </a:pPr>
+            <a:r>
+              <a:rPr sz="1500">
+                <a:solidFill>
+                  <a:srgbClr val="22282E"/>
+                </a:solidFill>
+              </a:rPr>
+              <a:t>•  ¿ChipWhisperer prueba que una implementación es insegura? Una práctica sobre un target educativo demuestra un fenómeno bajo condiciones concretas. Evaluar un producto exige modelo de amenaza…</a:t>
             </a:r>
           </a:p>
         </p:txBody>
@@ -3947,7 +3947,7 @@
                   <a:srgbClr val="0B3D2E"/>
                 </a:solidFill>
               </a:rPr>
-              <a:t>🔗 Referencias</a:t>
+              <a:t>🔗 Referencias verificables y alcance</a:t>
             </a:r>
           </a:p>
         </p:txBody>
@@ -3985,52 +3985,97 @@
                   <a:srgbClr val="22282E"/>
                 </a:solidFill>
               </a:rPr>
-              <a:t>•  The Hardware Hacking Handbook — Jasper van Woudenberg, Colin O'Flynn (No Starch Press).</a:t>
-            </a:r>
-          </a:p>
-          <a:p>
-            <a:pPr>
-              <a:spcAft>
-                <a:spcPts val="600"/>
-              </a:spcAft>
-            </a:pPr>
-            <a:r>
-              <a:rPr sz="1500">
-                <a:solidFill>
-                  <a:srgbClr val="22282E"/>
-                </a:solidFill>
-              </a:rPr>
-              <a:t>•  OpenOCD: &lt;https://openocd.org/&gt; · flashrom: &lt;https://www.flashrom.org/&gt;</a:t>
-            </a:r>
-          </a:p>
-          <a:p>
-            <a:pPr>
-              <a:spcAft>
-                <a:spcPts val="600"/>
-              </a:spcAft>
-            </a:pPr>
-            <a:r>
-              <a:rPr sz="1500">
-                <a:solidFill>
-                  <a:srgbClr val="22282E"/>
-                </a:solidFill>
-              </a:rPr>
-              <a:t>•  Practical IoT Hacking, caps. de hardware — Chantzis et al.</a:t>
-            </a:r>
-          </a:p>
-          <a:p>
-            <a:pPr>
-              <a:spcAft>
-                <a:spcPts val="600"/>
-              </a:spcAft>
-            </a:pPr>
-            <a:r>
-              <a:rPr sz="1500">
-                <a:solidFill>
-                  <a:srgbClr val="22282E"/>
-                </a:solidFill>
-              </a:rPr>
-              <a:t>•  JTAGulator (identificación de pinout): &lt;http://www.grandideastudio.com/jtagulator/&gt;</a:t>
+              <a:t>•  OpenOCD, User's Guide — separación entre configuración de adaptador, transporte y target.</a:t>
+            </a:r>
+          </a:p>
+          <a:p>
+            <a:pPr>
+              <a:spcAft>
+                <a:spcPts val="600"/>
+              </a:spcAft>
+            </a:pPr>
+            <a:r>
+              <a:rPr sz="1500">
+                <a:solidFill>
+                  <a:srgbClr val="22282E"/>
+                </a:solidFill>
+              </a:rPr>
+              <a:t>•  flashrom, documentación oficial — identificación, lectura, verificación, programadores y soporte por chip.</a:t>
+            </a:r>
+          </a:p>
+          <a:p>
+            <a:pPr>
+              <a:spcAft>
+                <a:spcPts val="600"/>
+              </a:spcAft>
+            </a:pPr>
+            <a:r>
+              <a:rPr sz="1500">
+                <a:solidFill>
+                  <a:srgbClr val="22282E"/>
+                </a:solidFill>
+              </a:rPr>
+              <a:t>•  Bus Pirate, Hardware y Logic analyzers — protocolos, diferencias de revisión y capacidades de captura.</a:t>
+            </a:r>
+          </a:p>
+          <a:p>
+            <a:pPr>
+              <a:spcAft>
+                <a:spcPts val="600"/>
+              </a:spcAft>
+            </a:pPr>
+            <a:r>
+              <a:rPr sz="1500">
+                <a:solidFill>
+                  <a:srgbClr val="22282E"/>
+                </a:solidFill>
+              </a:rPr>
+              <a:t>•  sigrok, proyecto oficial — captura y decodificación con hardware compatible.</a:t>
+            </a:r>
+          </a:p>
+          <a:p>
+            <a:pPr>
+              <a:spcAft>
+                <a:spcPts val="600"/>
+              </a:spcAft>
+            </a:pPr>
+            <a:r>
+              <a:rPr sz="1500">
+                <a:solidFill>
+                  <a:srgbClr val="22282E"/>
+                </a:solidFill>
+              </a:rPr>
+              <a:t>•  Arm, Debug Interface Architecture Specification — arquitectura JTAG/SWD; el soporte concreto depende del procesador.</a:t>
+            </a:r>
+          </a:p>
+          <a:p>
+            <a:pPr>
+              <a:spcAft>
+                <a:spcPts val="600"/>
+              </a:spcAft>
+            </a:pPr>
+            <a:r>
+              <a:rPr sz="1500">
+                <a:solidFill>
+                  <a:srgbClr val="22282E"/>
+                </a:solidFill>
+              </a:rPr>
+              <a:t>•  IEEE, IEEE 1149.1 — estándar de acceso de prueba JTAG.</a:t>
+            </a:r>
+          </a:p>
+          <a:p>
+            <a:pPr>
+              <a:spcAft>
+                <a:spcPts val="600"/>
+              </a:spcAft>
+            </a:pPr>
+            <a:r>
+              <a:rPr sz="1500">
+                <a:solidFill>
+                  <a:srgbClr val="22282E"/>
+                </a:solidFill>
+              </a:rPr>
+              <a:t>•  NewAE, ChipWhisperer: Getting Started — plataforma, componentes, análisis de potencia e inyección de fallos.</a:t>
             </a:r>
           </a:p>
         </p:txBody>
@@ -4088,7 +4133,7 @@
       </p:sp>
       <p:pic>
         <p:nvPicPr>
-          <p:cNvPr id="3" name="Picture 2" descr="45909bca47f98bbd.png"/>
+          <p:cNvPr id="3" name="Picture 2" descr="e942bed7eb4abd42.png"/>
           <p:cNvPicPr>
             <a:picLocks noChangeAspect="1"/>
           </p:cNvPicPr>
@@ -4102,8 +4147,8 @@
         </p:blipFill>
         <p:spPr>
           <a:xfrm>
-            <a:off x="1461800" y="1097280"/>
-            <a:ext cx="6220399" cy="5303520"/>
+            <a:off x="2642094" y="1097280"/>
+            <a:ext cx="3859811" cy="5303520"/>
           </a:xfrm>
           <a:prstGeom prst="rect">
             <a:avLst/>
@@ -4194,7 +4239,7 @@
                   <a:srgbClr val="22282E"/>
                 </a:solidFill>
               </a:rPr>
-              <a:t>•  Acceder al nivel más bajo de un dispositivo embebido a través de sus interfaces de depuración físicas: UART para obtener una consola serie, JTAG/SWD para control del procesador y volcado de memoria…</a:t>
+              <a:t>•  Investigar de forma no destructiva las interfaces físicas de un dispositivo embebido propio: reconocer la placa, medir niveles, observar UART/SPI, identificar JTAG o SWD, adquirir evidencia repetible…</a:t>
             </a:r>
           </a:p>
         </p:txBody>
@@ -4298,82 +4343,82 @@
                   <a:srgbClr val="22282E"/>
                 </a:solidFill>
               </a:rPr>
-              <a:t>•  Identificar interfaces UART, JTAG/SWD y SPI en una placa por inspección y medición.</a:t>
-            </a:r>
-          </a:p>
-          <a:p>
-            <a:pPr>
-              <a:spcAft>
-                <a:spcPts val="600"/>
-              </a:spcAft>
-            </a:pPr>
-            <a:r>
-              <a:rPr sz="1500">
-                <a:solidFill>
-                  <a:srgbClr val="22282E"/>
-                </a:solidFill>
-              </a:rPr>
-              <a:t>•  Conectar un adaptador USB-serie/lógico y obtener una consola UART.</a:t>
-            </a:r>
-          </a:p>
-          <a:p>
-            <a:pPr>
-              <a:spcAft>
-                <a:spcPts val="600"/>
-              </a:spcAft>
-            </a:pPr>
-            <a:r>
-              <a:rPr sz="1500">
-                <a:solidFill>
-                  <a:srgbClr val="22282E"/>
-                </a:solidFill>
-              </a:rPr>
-              <a:t>•  Usar JTAG/SWD con OpenOCD para detener el CPU y volcar memoria.</a:t>
-            </a:r>
-          </a:p>
-          <a:p>
-            <a:pPr>
-              <a:spcAft>
-                <a:spcPts val="600"/>
-              </a:spcAft>
-            </a:pPr>
-            <a:r>
-              <a:rPr sz="1500">
-                <a:solidFill>
-                  <a:srgbClr val="22282E"/>
-                </a:solidFill>
-              </a:rPr>
-              <a:t>•  Leer un chip de flash SPI con un programador (CH341A/Bus Pirate/flashrom).</a:t>
-            </a:r>
-          </a:p>
-          <a:p>
-            <a:pPr>
-              <a:spcAft>
-                <a:spcPts val="600"/>
-              </a:spcAft>
-            </a:pPr>
-            <a:r>
-              <a:rPr sz="1500">
-                <a:solidFill>
-                  <a:srgbClr val="22282E"/>
-                </a:solidFill>
-              </a:rPr>
-              <a:t>•  Interpretar señales con un analizador lógico para identificar protocolos.</a:t>
-            </a:r>
-          </a:p>
-          <a:p>
-            <a:pPr>
-              <a:spcAft>
-                <a:spcPts val="600"/>
-              </a:spcAft>
-            </a:pPr>
-            <a:r>
-              <a:rPr sz="1500">
-                <a:solidFill>
-                  <a:srgbClr val="22282E"/>
-                </a:solidFill>
-              </a:rPr>
-              <a:t>•  Extraer firmware o credenciales aprovechando el acceso físico.</a:t>
+              <a:t>•  Preparar un banco seguro con límite de corriente, tierra común, ESD, documentación y restauración.</a:t>
+            </a:r>
+          </a:p>
+          <a:p>
+            <a:pPr>
+              <a:spcAft>
+                <a:spcPts val="600"/>
+              </a:spcAft>
+            </a:pPr>
+            <a:r>
+              <a:rPr sz="1500">
+                <a:solidFill>
+                  <a:srgbClr val="22282E"/>
+                </a:solidFill>
+              </a:rPr>
+              <a:t>•  Identificar UART, JTAG/SWD y SPI mediante inspección, datasheet, continuidad y captura pasiva.</a:t>
+            </a:r>
+          </a:p>
+          <a:p>
+            <a:pPr>
+              <a:spcAft>
+                <a:spcPts val="600"/>
+              </a:spcAft>
+            </a:pPr>
+            <a:r>
+              <a:rPr sz="1500">
+                <a:solidFill>
+                  <a:srgbClr val="22282E"/>
+                </a:solidFill>
+              </a:rPr>
+              <a:t>•  Configurar adaptadores con el nivel lógico, orientación, velocidad y target correctos.</a:t>
+            </a:r>
+          </a:p>
+          <a:p>
+            <a:pPr>
+              <a:spcAft>
+                <a:spcPts val="600"/>
+              </a:spcAft>
+            </a:pPr>
+            <a:r>
+              <a:rPr sz="1500">
+                <a:solidFill>
+                  <a:srgbClr val="22282E"/>
+                </a:solidFill>
+              </a:rPr>
+              <a:t>•  Capturar un arranque UART y decodificar una transacción SPI sin escribir sobre el dispositivo.</a:t>
+            </a:r>
+          </a:p>
+          <a:p>
+            <a:pPr>
+              <a:spcAft>
+                <a:spcPts val="600"/>
+              </a:spcAft>
+            </a:pPr>
+            <a:r>
+              <a:rPr sz="1500">
+                <a:solidFill>
+                  <a:srgbClr val="22282E"/>
+                </a:solidFill>
+              </a:rPr>
+              <a:t>•  Adquirir dos lecturas de flash y aceptar la imagen solo si tamaño y hashes son coherentes.</a:t>
+            </a:r>
+          </a:p>
+          <a:p>
+            <a:pPr>
+              <a:spcAft>
+                <a:spcPts val="600"/>
+              </a:spcAft>
+            </a:pPr>
+            <a:r>
+              <a:rPr sz="1500">
+                <a:solidFill>
+                  <a:srgbClr val="22282E"/>
+                </a:solidFill>
+              </a:rPr>
+              <a:t>•  Explicar qué prueba una consola, un IDCODE, una traza o un volcado y qué permanece incierto.</a:t>
             </a:r>
           </a:p>
         </p:txBody>
@@ -4462,97 +4507,97 @@
                   <a:srgbClr val="22282E"/>
                 </a:solidFill>
               </a:rPr>
-              <a:t>•  1 — Seguridad eléctrica y voltajes</a:t>
-            </a:r>
-          </a:p>
-          <a:p>
-            <a:pPr>
-              <a:spcAft>
-                <a:spcPts val="600"/>
-              </a:spcAft>
-            </a:pPr>
-            <a:r>
-              <a:rPr sz="1500">
-                <a:solidFill>
-                  <a:srgbClr val="22282E"/>
-                </a:solidFill>
-              </a:rPr>
-              <a:t>•  2 — Identificación de puertos en PCB</a:t>
-            </a:r>
-          </a:p>
-          <a:p>
-            <a:pPr>
-              <a:spcAft>
-                <a:spcPts val="600"/>
-              </a:spcAft>
-            </a:pPr>
-            <a:r>
-              <a:rPr sz="1500">
-                <a:solidFill>
-                  <a:srgbClr val="22282E"/>
-                </a:solidFill>
-              </a:rPr>
-              <a:t>•  3 — UART: consola serie</a:t>
-            </a:r>
-          </a:p>
-          <a:p>
-            <a:pPr>
-              <a:spcAft>
-                <a:spcPts val="600"/>
-              </a:spcAft>
-            </a:pPr>
-            <a:r>
-              <a:rPr sz="1500">
-                <a:solidFill>
-                  <a:srgbClr val="22282E"/>
-                </a:solidFill>
-              </a:rPr>
-              <a:t>•  4 — Analizador lógico</a:t>
-            </a:r>
-          </a:p>
-          <a:p>
-            <a:pPr>
-              <a:spcAft>
-                <a:spcPts val="600"/>
-              </a:spcAft>
-            </a:pPr>
-            <a:r>
-              <a:rPr sz="1500">
-                <a:solidFill>
-                  <a:srgbClr val="22282E"/>
-                </a:solidFill>
-              </a:rPr>
-              <a:t>•  5 — JTAG/SWD con OpenOCD</a:t>
-            </a:r>
-          </a:p>
-          <a:p>
-            <a:pPr>
-              <a:spcAft>
-                <a:spcPts val="600"/>
-              </a:spcAft>
-            </a:pPr>
-            <a:r>
-              <a:rPr sz="1500">
-                <a:solidFill>
-                  <a:srgbClr val="22282E"/>
-                </a:solidFill>
-              </a:rPr>
-              <a:t>•  6 — SPI y volcado de flash</a:t>
-            </a:r>
-          </a:p>
-          <a:p>
-            <a:pPr>
-              <a:spcAft>
-                <a:spcPts val="600"/>
-              </a:spcAft>
-            </a:pPr>
-            <a:r>
-              <a:rPr sz="1500">
-                <a:solidFill>
-                  <a:srgbClr val="22282E"/>
-                </a:solidFill>
-              </a:rPr>
-              <a:t>•  7 — Contramedidas del fabricante</a:t>
+              <a:t>•  1 — Seguridad eléctrica y ESD</a:t>
+            </a:r>
+          </a:p>
+          <a:p>
+            <a:pPr>
+              <a:spcAft>
+                <a:spcPts val="600"/>
+              </a:spcAft>
+            </a:pPr>
+            <a:r>
+              <a:rPr sz="1500">
+                <a:solidFill>
+                  <a:srgbClr val="22282E"/>
+                </a:solidFill>
+              </a:rPr>
+              <a:t>•  2 — Reconocimiento de PCB</a:t>
+            </a:r>
+          </a:p>
+          <a:p>
+            <a:pPr>
+              <a:spcAft>
+                <a:spcPts val="600"/>
+              </a:spcAft>
+            </a:pPr>
+            <a:r>
+              <a:rPr sz="1500">
+                <a:solidFill>
+                  <a:srgbClr val="22282E"/>
+                </a:solidFill>
+              </a:rPr>
+              <a:t>•  3 — UART</a:t>
+            </a:r>
+          </a:p>
+          <a:p>
+            <a:pPr>
+              <a:spcAft>
+                <a:spcPts val="600"/>
+              </a:spcAft>
+            </a:pPr>
+            <a:r>
+              <a:rPr sz="1500">
+                <a:solidFill>
+                  <a:srgbClr val="22282E"/>
+                </a:solidFill>
+              </a:rPr>
+              <a:t>•  4 — Analizador lógico y Bus Pirate</a:t>
+            </a:r>
+          </a:p>
+          <a:p>
+            <a:pPr>
+              <a:spcAft>
+                <a:spcPts val="600"/>
+              </a:spcAft>
+            </a:pPr>
+            <a:r>
+              <a:rPr sz="1500">
+                <a:solidFill>
+                  <a:srgbClr val="22282E"/>
+                </a:solidFill>
+              </a:rPr>
+              <a:t>•  5 — JTAG/SWD y OpenOCD</a:t>
+            </a:r>
+          </a:p>
+          <a:p>
+            <a:pPr>
+              <a:spcAft>
+                <a:spcPts val="600"/>
+              </a:spcAft>
+            </a:pPr>
+            <a:r>
+              <a:rPr sz="1500">
+                <a:solidFill>
+                  <a:srgbClr val="22282E"/>
+                </a:solidFill>
+              </a:rPr>
+              <a:t>•  6 — SPI y flashrom</a:t>
+            </a:r>
+          </a:p>
+          <a:p>
+            <a:pPr>
+              <a:spcAft>
+                <a:spcPts val="600"/>
+              </a:spcAft>
+            </a:pPr>
+            <a:r>
+              <a:rPr sz="1500">
+                <a:solidFill>
+                  <a:srgbClr val="22282E"/>
+                </a:solidFill>
+              </a:rPr>
+              <a:t>•  7 — Protección de producción</a:t>
             </a:r>
           </a:p>
         </p:txBody>
@@ -4641,52 +4686,97 @@
                   <a:srgbClr val="22282E"/>
                 </a:solidFill>
               </a:rPr>
-              <a:t>•  UART, JTAG/SWD y SPI cumplen funciones diferentes. UART es una consola serie asíncrona; JTAG/SWD ofrece depuración y prueba del chip; SPI conecta periféricos, con frecuencia flash. Encontrar pines no…</a:t>
-            </a:r>
-          </a:p>
-          <a:p>
-            <a:pPr>
-              <a:spcAft>
-                <a:spcPts val="600"/>
-              </a:spcAft>
-            </a:pPr>
-            <a:r>
-              <a:rPr sz="1500">
-                <a:solidFill>
-                  <a:srgbClr val="22282E"/>
-                </a:solidFill>
-              </a:rPr>
-              <a:t>•  La primera práctica es pasiva: fotografías, continuidad con el equipo apagado y analizador lógico de alta impedancia. En UART se comparte tierra, se confirma nivel —a menudo 3,3 V o 1,8 V— y se…</a:t>
-            </a:r>
-          </a:p>
-          <a:p>
-            <a:pPr>
-              <a:spcAft>
-                <a:spcPts val="600"/>
-              </a:spcAft>
-            </a:pPr>
-            <a:r>
-              <a:rPr sz="1500">
-                <a:solidFill>
-                  <a:srgbClr val="22282E"/>
-                </a:solidFill>
-              </a:rPr>
-              <a:t>•  En JTAG/SWD, deshabilitar depuración en producción puede ser apropiado, pero debe conservarse una ruta segura de fabricación y recuperación. Los fusibles son potencialmente irreversibles y nunca se…</a:t>
-            </a:r>
-          </a:p>
-          <a:p>
-            <a:pPr>
-              <a:spcAft>
-                <a:spcPts val="600"/>
-              </a:spcAft>
-            </a:pPr>
-            <a:r>
-              <a:rPr sz="1500">
-                <a:solidFill>
-                  <a:srgbClr val="22282E"/>
-                </a:solidFill>
-              </a:rPr>
-              <a:t>•  Tres lecturas de flash producen hashes distintos. Antes de analizar «firmware cambiante», el alumno revisa alimentación, contacto y contención del bus. Solo cuando las lecturas coinciden se acepta…</a:t>
+              <a:t>•  Una hilera de cuatro pines no «es UART» por su forma. Puede transportar alimentación, I²C, SWD o señales propietarias. El análisis empieza con el dispositivo apagado: fotografía ambas caras…</a:t>
+            </a:r>
+          </a:p>
+          <a:p>
+            <a:pPr>
+              <a:spcAft>
+                <a:spcPts val="600"/>
+              </a:spcAft>
+            </a:pPr>
+            <a:r>
+              <a:rPr sz="1500">
+                <a:solidFill>
+                  <a:srgbClr val="22282E"/>
+                </a:solidFill>
+              </a:rPr>
+              <a:t>•  El nivel lógico es una propiedad eléctrica, no el número «serial» en el sistema operativo. TTL/CMOS de 1,8 V o 3,3 V no es RS-232, que usa tensiones incompatibles. Una línea que parece inactiva puede…</a:t>
+            </a:r>
+          </a:p>
+          <a:p>
+            <a:pPr>
+              <a:spcAft>
+                <a:spcPts val="600"/>
+              </a:spcAft>
+            </a:pPr>
+            <a:r>
+              <a:rPr sz="1500">
+                <a:solidFill>
+                  <a:srgbClr val="22282E"/>
+                </a:solidFill>
+              </a:rPr>
+              <a:t>•  El diagrama no promete que toda rama produzca acceso. Muestra un embudo de reducción de incertidumbre. Solo después de confirmar señales se selecciona un instrumento activo. El resultado válido puede…</a:t>
+            </a:r>
+          </a:p>
+          <a:p>
+            <a:pPr>
+              <a:spcAft>
+                <a:spcPts val="600"/>
+              </a:spcAft>
+            </a:pPr>
+            <a:r>
+              <a:rPr sz="1500">
+                <a:solidFill>
+                  <a:srgbClr val="22282E"/>
+                </a:solidFill>
+              </a:rPr>
+              <a:t>•  UART es comunicación serie asíncrona: no lleva reloj compartido y depende de velocidad, bits de datos, paridad y parada. En una placa suelen interesar TX del objetivo, RX del objetivo y GND. Escuchar…</a:t>
+            </a:r>
+          </a:p>
+          <a:p>
+            <a:pPr>
+              <a:spcAft>
+                <a:spcPts val="600"/>
+              </a:spcAft>
+            </a:pPr>
+            <a:r>
+              <a:rPr sz="1500">
+                <a:solidFill>
+                  <a:srgbClr val="22282E"/>
+                </a:solidFill>
+              </a:rPr>
+              <a:t>•  Los logs pueden revelar versiones, particiones, argumentos de kernel, errores y nombres de interfaces. Son evidencia sensible. El control no consiste únicamente en quitar el header: se eliminan…</a:t>
+            </a:r>
+          </a:p>
+          <a:p>
+            <a:pPr>
+              <a:spcAft>
+                <a:spcPts val="600"/>
+              </a:spcAft>
+            </a:pPr>
+            <a:r>
+              <a:rPr sz="1500">
+                <a:solidFill>
+                  <a:srgbClr val="22282E"/>
+                </a:solidFill>
+              </a:rPr>
+              <a:t>•  JTAG es un estándar de prueba y depuración con cadena de dispositivos; SWD es una interfaz de depuración de dos señales común en microcontroladores Arm. Un pinout supuesto y un archivo de target…</a:t>
+            </a:r>
+          </a:p>
+          <a:p>
+            <a:pPr>
+              <a:spcAft>
+                <a:spcPts val="600"/>
+              </a:spcAft>
+            </a:pPr>
+            <a:r>
+              <a:rPr sz="1500">
+                <a:solidFill>
+                  <a:srgbClr val="22282E"/>
+                </a:solidFill>
+              </a:rPr>
+              <a:t>•  Leer un IDCODE consistente o conectar al Debug Access Port demuestra que la ruta responde. No demuestra que toda memoria sea legible. Los microcontroladores implementan niveles de protección…</a:t>
             </a:r>
           </a:p>
         </p:txBody>
@@ -4737,7 +4827,7 @@
                   <a:srgbClr val="0B3D2E"/>
                 </a:solidFill>
               </a:rPr>
-              <a:t>📔 Glosario operativo</a:t>
+              <a:t>📖 Definiciones y características</a:t>
             </a:r>
           </a:p>
         </p:txBody>
@@ -4775,82 +4865,97 @@
                   <a:srgbClr val="22282E"/>
                 </a:solidFill>
               </a:rPr>
-              <a:t>•  Término — Definición útil</a:t>
-            </a:r>
-          </a:p>
-          <a:p>
-            <a:pPr>
-              <a:spcAft>
-                <a:spcPts val="600"/>
-              </a:spcAft>
-            </a:pPr>
-            <a:r>
-              <a:rPr sz="1500">
-                <a:solidFill>
-                  <a:srgbClr val="22282E"/>
-                </a:solidFill>
-              </a:rPr>
-              <a:t>•  UART — Enlace serie asíncrono con RX/TX y referencia común.</a:t>
-            </a:r>
-          </a:p>
-          <a:p>
-            <a:pPr>
-              <a:spcAft>
-                <a:spcPts val="600"/>
-              </a:spcAft>
-            </a:pPr>
-            <a:r>
-              <a:rPr sz="1500">
-                <a:solidFill>
-                  <a:srgbClr val="22282E"/>
-                </a:solidFill>
-              </a:rPr>
-              <a:t>•  JTAG/SWD — Interfaces de depuración y prueba de circuitos.</a:t>
-            </a:r>
-          </a:p>
-          <a:p>
-            <a:pPr>
-              <a:spcAft>
-                <a:spcPts val="600"/>
-              </a:spcAft>
-            </a:pPr>
-            <a:r>
-              <a:rPr sz="1500">
-                <a:solidFill>
-                  <a:srgbClr val="22282E"/>
-                </a:solidFill>
-              </a:rPr>
-              <a:t>•  SPI — Bus síncrono usado por memorias y periféricos.</a:t>
-            </a:r>
-          </a:p>
-          <a:p>
-            <a:pPr>
-              <a:spcAft>
-                <a:spcPts val="600"/>
-              </a:spcAft>
-            </a:pPr>
-            <a:r>
-              <a:rPr sz="1500">
-                <a:solidFill>
-                  <a:srgbClr val="22282E"/>
-                </a:solidFill>
-              </a:rPr>
-              <a:t>•  Nivel lógico — Tensión que representa estados digitales; no asumir 5 V.</a:t>
-            </a:r>
-          </a:p>
-          <a:p>
-            <a:pPr>
-              <a:spcAft>
-                <a:spcPts val="600"/>
-              </a:spcAft>
-            </a:pPr>
-            <a:r>
-              <a:rPr sz="1500">
-                <a:solidFill>
-                  <a:srgbClr val="22282E"/>
-                </a:solidFill>
-              </a:rPr>
-              <a:t>•  Contención — Dos dispositivos conducen una línea de manera incompatible.</a:t>
+              <a:t>•  UART: enlace serie asíncrono; una consola puede ser solo salida, interactiva o autenticada.</a:t>
+            </a:r>
+          </a:p>
+          <a:p>
+            <a:pPr>
+              <a:spcAft>
+                <a:spcPts val="600"/>
+              </a:spcAft>
+            </a:pPr>
+            <a:r>
+              <a:rPr sz="1500">
+                <a:solidFill>
+                  <a:srgbClr val="22282E"/>
+                </a:solidFill>
+              </a:rPr>
+              <a:t>•  JTAG: interfaz de prueba/depuración con cadena y señales de reloj/datos/control.</a:t>
+            </a:r>
+          </a:p>
+          <a:p>
+            <a:pPr>
+              <a:spcAft>
+                <a:spcPts val="600"/>
+              </a:spcAft>
+            </a:pPr>
+            <a:r>
+              <a:rPr sz="1500">
+                <a:solidFill>
+                  <a:srgbClr val="22282E"/>
+                </a:solidFill>
+              </a:rPr>
+              <a:t>•  SWD: interfaz de depuración Arm con menos señales que JTAG; las capacidades dependen del target.</a:t>
+            </a:r>
+          </a:p>
+          <a:p>
+            <a:pPr>
+              <a:spcAft>
+                <a:spcPts val="600"/>
+              </a:spcAft>
+            </a:pPr>
+            <a:r>
+              <a:rPr sz="1500">
+                <a:solidFill>
+                  <a:srgbClr val="22282E"/>
+                </a:solidFill>
+              </a:rPr>
+              <a:t>•  SPI: bus serie síncrono controlador-periférico; el chip select delimita el dispositivo activo.</a:t>
+            </a:r>
+          </a:p>
+          <a:p>
+            <a:pPr>
+              <a:spcAft>
+                <a:spcPts val="600"/>
+              </a:spcAft>
+            </a:pPr>
+            <a:r>
+              <a:rPr sz="1500">
+                <a:solidFill>
+                  <a:srgbClr val="22282E"/>
+                </a:solidFill>
+              </a:rPr>
+              <a:t>•  HiZ: alta impedancia; estado que evita conducir activamente una línea.</a:t>
+            </a:r>
+          </a:p>
+          <a:p>
+            <a:pPr>
+              <a:spcAft>
+                <a:spcPts val="600"/>
+              </a:spcAft>
+            </a:pPr>
+            <a:r>
+              <a:rPr sz="1500">
+                <a:solidFill>
+                  <a:srgbClr val="22282E"/>
+                </a:solidFill>
+              </a:rPr>
+              <a:t>•  Contención eléctrica: dos salidas conducen valores incompatibles sobre la misma línea.</a:t>
+            </a:r>
+          </a:p>
+          <a:p>
+            <a:pPr>
+              <a:spcAft>
+                <a:spcPts val="600"/>
+              </a:spcAft>
+            </a:pPr>
+            <a:r>
+              <a:rPr sz="1500">
+                <a:solidFill>
+                  <a:srgbClr val="22282E"/>
+                </a:solidFill>
+              </a:rPr>
+              <a:t>•  IDCODE: identificador leído por ciertas rutas JTAG; orienta la identificación, no autoriza memoria.</a:t>
             </a:r>
           </a:p>
         </p:txBody>
@@ -4901,7 +5006,7 @@
                   <a:srgbClr val="0B3D2E"/>
                 </a:solidFill>
               </a:rPr>
-              <a:t>✅ Criterio de dominio</a:t>
+              <a:t>📔 Glosario operativo</a:t>
             </a:r>
           </a:p>
         </p:txBody>
@@ -4939,7 +5044,97 @@
                   <a:srgbClr val="22282E"/>
                 </a:solidFill>
               </a:rPr>
-              <a:t>•  Hay dominio cuando el alumno identifica una interfaz sin dañar la placa, documenta niveles y pinout, obtiene lecturas repetibles en modo no destructivo y explica cómo reducir acceso de producción…</a:t>
+              <a:t>•  Término — Definición útil</a:t>
+            </a:r>
+          </a:p>
+          <a:p>
+            <a:pPr>
+              <a:spcAft>
+                <a:spcPts val="600"/>
+              </a:spcAft>
+            </a:pPr>
+            <a:r>
+              <a:rPr sz="1500">
+                <a:solidFill>
+                  <a:srgbClr val="22282E"/>
+                </a:solidFill>
+              </a:rPr>
+              <a:t>•  DUT/target — Dispositivo bajo prueba.</a:t>
+            </a:r>
+          </a:p>
+          <a:p>
+            <a:pPr>
+              <a:spcAft>
+                <a:spcPts val="600"/>
+              </a:spcAft>
+            </a:pPr>
+            <a:r>
+              <a:rPr sz="1500">
+                <a:solidFill>
+                  <a:srgbClr val="22282E"/>
+                </a:solidFill>
+              </a:rPr>
+              <a:t>•  GND — Referencia eléctrica común; se identifica antes de conectar señales.</a:t>
+            </a:r>
+          </a:p>
+          <a:p>
+            <a:pPr>
+              <a:spcAft>
+                <a:spcPts val="600"/>
+              </a:spcAft>
+            </a:pPr>
+            <a:r>
+              <a:rPr sz="1500">
+                <a:solidFill>
+                  <a:srgbClr val="22282E"/>
+                </a:solidFill>
+              </a:rPr>
+              <a:t>•  Baud — Tasa de símbolos de UART; no siempre equivale a bits útiles por segundo.</a:t>
+            </a:r>
+          </a:p>
+          <a:p>
+            <a:pPr>
+              <a:spcAft>
+                <a:spcPts val="600"/>
+              </a:spcAft>
+            </a:pPr>
+            <a:r>
+              <a:rPr sz="1500">
+                <a:solidFill>
+                  <a:srgbClr val="22282E"/>
+                </a:solidFill>
+              </a:rPr>
+              <a:t>•  Pinout — Asignación documentada de función a cada pin.</a:t>
+            </a:r>
+          </a:p>
+          <a:p>
+            <a:pPr>
+              <a:spcAft>
+                <a:spcPts val="600"/>
+              </a:spcAft>
+            </a:pPr>
+            <a:r>
+              <a:rPr sz="1500">
+                <a:solidFill>
+                  <a:srgbClr val="22282E"/>
+                </a:solidFill>
+              </a:rPr>
+              <a:t>•  SoC — Sistema en chip que integra procesador y periféricos.</a:t>
+            </a:r>
+          </a:p>
+          <a:p>
+            <a:pPr>
+              <a:spcAft>
+                <a:spcPts val="600"/>
+              </a:spcAft>
+            </a:pPr>
+            <a:r>
+              <a:rPr sz="1500">
+                <a:solidFill>
+                  <a:srgbClr val="22282E"/>
+                </a:solidFill>
+              </a:rPr>
+              <a:t>•  NOR flash — Memoria no volátil común en firmware embebido.</a:t>
             </a:r>
           </a:p>
         </p:txBody>
@@ -4990,7 +5185,7 @@
                   <a:srgbClr val="0B3D2E"/>
                 </a:solidFill>
               </a:rPr>
-              <a:t>📖 Definiciones y características</a:t>
+              <a:t>✅ Criterio de dominio</a:t>
             </a:r>
           </a:p>
         </p:txBody>
@@ -5028,82 +5223,7 @@
                   <a:srgbClr val="22282E"/>
                 </a:solidFill>
               </a:rPr>
-              <a:t>•  UART: comunicación serie asíncrona (TX, RX, GND, VCC) usada para consolas de depuración. Característica: a menudo expone un shell root sin autenticación.</a:t>
-            </a:r>
-          </a:p>
-          <a:p>
-            <a:pPr>
-              <a:spcAft>
-                <a:spcPts val="600"/>
-              </a:spcAft>
-            </a:pPr>
-            <a:r>
-              <a:rPr sz="1500">
-                <a:solidFill>
-                  <a:srgbClr val="22282E"/>
-                </a:solidFill>
-              </a:rPr>
-              <a:t>•  JTAG/SWD: interfaz de depuración que controla el procesador (leer/escribir registros y memoria). Característica: permite volcar RAM/flash y saltar protecciones.</a:t>
-            </a:r>
-          </a:p>
-          <a:p>
-            <a:pPr>
-              <a:spcAft>
-                <a:spcPts val="600"/>
-              </a:spcAft>
-            </a:pPr>
-            <a:r>
-              <a:rPr sz="1500">
-                <a:solidFill>
-                  <a:srgbClr val="22282E"/>
-                </a:solidFill>
-              </a:rPr>
-              <a:t>•  SPI: bus serie síncrono (MOSI, MISO, CLK, CS) que conecta el CPU al chip de flash. Característica: se puede leer el flash directamente con un programador.</a:t>
-            </a:r>
-          </a:p>
-          <a:p>
-            <a:pPr>
-              <a:spcAft>
-                <a:spcPts val="600"/>
-              </a:spcAft>
-            </a:pPr>
-            <a:r>
-              <a:rPr sz="1500">
-                <a:solidFill>
-                  <a:srgbClr val="22282E"/>
-                </a:solidFill>
-              </a:rPr>
-              <a:t>•  Analizador lógico: dispositivo que captura señales digitales para decodificar protocolos. Característica: identifica baud rate y pinout desconocidos.</a:t>
-            </a:r>
-          </a:p>
-          <a:p>
-            <a:pPr>
-              <a:spcAft>
-                <a:spcPts val="600"/>
-              </a:spcAft>
-            </a:pPr>
-            <a:r>
-              <a:rPr sz="1500">
-                <a:solidFill>
-                  <a:srgbClr val="22282E"/>
-                </a:solidFill>
-              </a:rPr>
-              <a:t>•  OpenOCD: software que habla JTAG/SWD con adaptadores para depuración y volcado. Característica: soporta multitud de targets ARM/MIPS.</a:t>
-            </a:r>
-          </a:p>
-          <a:p>
-            <a:pPr>
-              <a:spcAft>
-                <a:spcPts val="600"/>
-              </a:spcAft>
-            </a:pPr>
-            <a:r>
-              <a:rPr sz="1500">
-                <a:solidFill>
-                  <a:srgbClr val="22282E"/>
-                </a:solidFill>
-              </a:rPr>
-              <a:t>•  flashrom: utilidad para leer/escribir chips de flash SPI. Característica: soporta muchos programadores (CH341A, Bus Pirate).</a:t>
+              <a:t>•  Hay dominio cuando el alumno formula y confirma un pinout sin depender de la forma del conector, registra tensión y parámetros, obtiene evidencia pasiva interpretable, acepta un volcado solo por…</a:t>
             </a:r>
           </a:p>
         </p:txBody>
@@ -5192,22 +5312,37 @@
                   <a:srgbClr val="22282E"/>
                 </a:solidFill>
               </a:rPr>
-              <a:t>•  Adaptador USB-UART (FTDI/CP2102), multímetro, analizador lógico (Saleae/clon), programador SPI (CH341A) o Bus Pirate, JTAG/SWD (J-Link, FT2232, ST-Link).</a:t>
-            </a:r>
-          </a:p>
-          <a:p>
-            <a:pPr>
-              <a:spcAft>
-                <a:spcPts val="600"/>
-              </a:spcAft>
-            </a:pPr>
-            <a:r>
-              <a:rPr sz="1500">
-                <a:solidFill>
-                  <a:srgbClr val="22282E"/>
-                </a:solidFill>
-              </a:rPr>
-              <a:t>•  Cables Dupont, pinza de test (SOIC clip) para leer flash sin desoldar.</a:t>
+              <a:t>•  Banco recomendado: placa educativa o router retirado y propio; fuente con límite de corriente; tapete ESD; multímetro; analizador lógico compatible con sigrok; adaptador USB-UART con nivel…</a:t>
+            </a:r>
+          </a:p>
+          <a:p>
+            <a:pPr>
+              <a:spcAft>
+                <a:spcPts val="600"/>
+              </a:spcAft>
+            </a:pPr>
+            <a:r>
+              <a:rPr sz="1500">
+                <a:solidFill>
+                  <a:srgbClr val="22282E"/>
+                </a:solidFill>
+              </a:rPr>
+              <a:t>•  Administración del instrumental: anota modelo, revisión, firmware y controladores; actualiza desde el proyecto/fabricante; respalda configuraciones; no guardes firmware de clientes en almacenamiento…</a:t>
+            </a:r>
+          </a:p>
+          <a:p>
+            <a:pPr>
+              <a:spcAft>
+                <a:spcPts val="600"/>
+              </a:spcAft>
+            </a:pPr>
+            <a:r>
+              <a:rPr sz="1500">
+                <a:solidFill>
+                  <a:srgbClr val="22282E"/>
+                </a:solidFill>
+              </a:rPr>
+              <a:t>•  No copies literalmente &lt;sonda&gt;, &lt;mcu-exacto&gt; ni &lt;programador&gt;: son marcadores que obligan a seleccionar configuración documentada. No se usa -w en esta práctica.</a:t>
             </a:r>
           </a:p>
         </p:txBody>

</xml_diff>